<commit_message>
Animations in day 2 (chunks 6-10)
</commit_message>
<xml_diff>
--- a/Lecture Resources/Lecture Powerpoints/Chunk 10 - 2D numpy and mpl.pptx
+++ b/Lecture Resources/Lecture Powerpoints/Chunk 10 - 2D numpy and mpl.pptx
@@ -133,6 +133,99 @@
 
 <file path=ppt/changesInfos/changesInfo1.xml><?xml version="1.0" encoding="utf-8"?>
 <pc:chgInfo xmlns:a="http://schemas.openxmlformats.org/drawingml/2006/main" xmlns:r="http://schemas.openxmlformats.org/officeDocument/2006/relationships" xmlns:ac="http://schemas.microsoft.com/office/drawing/2013/main/command" xmlns:pc="http://schemas.microsoft.com/office/powerpoint/2013/main/command">
+  <pc:docChgLst>
+    <pc:chgData name="Jonathan Bollig" userId="8b5d0afe-f106-45e0-8c3f-fd98fa124db1" providerId="ADAL" clId="{891409C9-2319-433B-8001-2E1CE368518E}"/>
+    <pc:docChg chg="custSel addSld delSld modSld">
+      <pc:chgData name="Jonathan Bollig" userId="8b5d0afe-f106-45e0-8c3f-fd98fa124db1" providerId="ADAL" clId="{891409C9-2319-433B-8001-2E1CE368518E}" dt="2025-08-18T13:33:56.347" v="46" actId="47"/>
+      <pc:docMkLst>
+        <pc:docMk/>
+      </pc:docMkLst>
+      <pc:sldChg chg="modSp mod">
+        <pc:chgData name="Jonathan Bollig" userId="8b5d0afe-f106-45e0-8c3f-fd98fa124db1" providerId="ADAL" clId="{891409C9-2319-433B-8001-2E1CE368518E}" dt="2025-08-18T10:03:07.320" v="7" actId="20577"/>
+        <pc:sldMkLst>
+          <pc:docMk/>
+          <pc:sldMk cId="836289018" sldId="256"/>
+        </pc:sldMkLst>
+      </pc:sldChg>
+      <pc:sldChg chg="del">
+        <pc:chgData name="Jonathan Bollig" userId="8b5d0afe-f106-45e0-8c3f-fd98fa124db1" providerId="ADAL" clId="{891409C9-2319-433B-8001-2E1CE368518E}" dt="2025-08-18T09:57:07.527" v="0" actId="47"/>
+        <pc:sldMkLst>
+          <pc:docMk/>
+          <pc:sldMk cId="3656329933" sldId="257"/>
+        </pc:sldMkLst>
+      </pc:sldChg>
+      <pc:sldChg chg="del">
+        <pc:chgData name="Jonathan Bollig" userId="8b5d0afe-f106-45e0-8c3f-fd98fa124db1" providerId="ADAL" clId="{891409C9-2319-433B-8001-2E1CE368518E}" dt="2025-08-18T09:57:07.527" v="0" actId="47"/>
+        <pc:sldMkLst>
+          <pc:docMk/>
+          <pc:sldMk cId="544279955" sldId="258"/>
+        </pc:sldMkLst>
+      </pc:sldChg>
+      <pc:sldChg chg="delSp modSp del mod">
+        <pc:chgData name="Jonathan Bollig" userId="8b5d0afe-f106-45e0-8c3f-fd98fa124db1" providerId="ADAL" clId="{891409C9-2319-433B-8001-2E1CE368518E}" dt="2025-08-18T13:33:56.347" v="46" actId="47"/>
+        <pc:sldMkLst>
+          <pc:docMk/>
+          <pc:sldMk cId="2169503629" sldId="259"/>
+        </pc:sldMkLst>
+      </pc:sldChg>
+      <pc:sldChg chg="add">
+        <pc:chgData name="Jonathan Bollig" userId="8b5d0afe-f106-45e0-8c3f-fd98fa124db1" providerId="ADAL" clId="{891409C9-2319-433B-8001-2E1CE368518E}" dt="2025-08-18T13:33:54.473" v="45"/>
+        <pc:sldMkLst>
+          <pc:docMk/>
+          <pc:sldMk cId="932306145" sldId="260"/>
+        </pc:sldMkLst>
+      </pc:sldChg>
+      <pc:sldChg chg="del">
+        <pc:chgData name="Jonathan Bollig" userId="8b5d0afe-f106-45e0-8c3f-fd98fa124db1" providerId="ADAL" clId="{891409C9-2319-433B-8001-2E1CE368518E}" dt="2025-08-18T09:57:07.527" v="0" actId="47"/>
+        <pc:sldMkLst>
+          <pc:docMk/>
+          <pc:sldMk cId="2533283895" sldId="260"/>
+        </pc:sldMkLst>
+      </pc:sldChg>
+      <pc:sldChg chg="del">
+        <pc:chgData name="Jonathan Bollig" userId="8b5d0afe-f106-45e0-8c3f-fd98fa124db1" providerId="ADAL" clId="{891409C9-2319-433B-8001-2E1CE368518E}" dt="2025-08-18T09:57:07.527" v="0" actId="47"/>
+        <pc:sldMkLst>
+          <pc:docMk/>
+          <pc:sldMk cId="847849653" sldId="261"/>
+        </pc:sldMkLst>
+      </pc:sldChg>
+      <pc:sldChg chg="del">
+        <pc:chgData name="Jonathan Bollig" userId="8b5d0afe-f106-45e0-8c3f-fd98fa124db1" providerId="ADAL" clId="{891409C9-2319-433B-8001-2E1CE368518E}" dt="2025-08-18T09:57:07.527" v="0" actId="47"/>
+        <pc:sldMkLst>
+          <pc:docMk/>
+          <pc:sldMk cId="1908144578" sldId="262"/>
+        </pc:sldMkLst>
+      </pc:sldChg>
+      <pc:sldChg chg="del">
+        <pc:chgData name="Jonathan Bollig" userId="8b5d0afe-f106-45e0-8c3f-fd98fa124db1" providerId="ADAL" clId="{891409C9-2319-433B-8001-2E1CE368518E}" dt="2025-08-18T09:57:07.527" v="0" actId="47"/>
+        <pc:sldMkLst>
+          <pc:docMk/>
+          <pc:sldMk cId="4076698392" sldId="263"/>
+        </pc:sldMkLst>
+      </pc:sldChg>
+      <pc:sldChg chg="del">
+        <pc:chgData name="Jonathan Bollig" userId="8b5d0afe-f106-45e0-8c3f-fd98fa124db1" providerId="ADAL" clId="{891409C9-2319-433B-8001-2E1CE368518E}" dt="2025-08-18T09:57:07.527" v="0" actId="47"/>
+        <pc:sldMkLst>
+          <pc:docMk/>
+          <pc:sldMk cId="3708449378" sldId="264"/>
+        </pc:sldMkLst>
+      </pc:sldChg>
+      <pc:sldChg chg="del">
+        <pc:chgData name="Jonathan Bollig" userId="8b5d0afe-f106-45e0-8c3f-fd98fa124db1" providerId="ADAL" clId="{891409C9-2319-433B-8001-2E1CE368518E}" dt="2025-08-18T09:57:07.527" v="0" actId="47"/>
+        <pc:sldMkLst>
+          <pc:docMk/>
+          <pc:sldMk cId="933916611" sldId="265"/>
+        </pc:sldMkLst>
+      </pc:sldChg>
+      <pc:sldChg chg="del">
+        <pc:chgData name="Jonathan Bollig" userId="8b5d0afe-f106-45e0-8c3f-fd98fa124db1" providerId="ADAL" clId="{891409C9-2319-433B-8001-2E1CE368518E}" dt="2025-08-18T09:57:07.527" v="0" actId="47"/>
+        <pc:sldMkLst>
+          <pc:docMk/>
+          <pc:sldMk cId="2117799034" sldId="266"/>
+        </pc:sldMkLst>
+      </pc:sldChg>
+    </pc:docChg>
+  </pc:docChgLst>
   <pc:docChgLst>
     <pc:chgData name="Jonathan Bollig" userId="8b5d0afe-f106-45e0-8c3f-fd98fa124db1" providerId="ADAL" clId="{B108959E-8160-4214-BA0D-42D2F1070C03}"/>
     <pc:docChg chg="undo custSel addSld modSld sldOrd">
@@ -749,99 +842,6 @@
       </pc:sldChg>
     </pc:docChg>
   </pc:docChgLst>
-  <pc:docChgLst>
-    <pc:chgData name="Jonathan Bollig" userId="8b5d0afe-f106-45e0-8c3f-fd98fa124db1" providerId="ADAL" clId="{891409C9-2319-433B-8001-2E1CE368518E}"/>
-    <pc:docChg chg="custSel addSld delSld modSld">
-      <pc:chgData name="Jonathan Bollig" userId="8b5d0afe-f106-45e0-8c3f-fd98fa124db1" providerId="ADAL" clId="{891409C9-2319-433B-8001-2E1CE368518E}" dt="2025-08-18T13:33:56.347" v="46" actId="47"/>
-      <pc:docMkLst>
-        <pc:docMk/>
-      </pc:docMkLst>
-      <pc:sldChg chg="modSp mod">
-        <pc:chgData name="Jonathan Bollig" userId="8b5d0afe-f106-45e0-8c3f-fd98fa124db1" providerId="ADAL" clId="{891409C9-2319-433B-8001-2E1CE368518E}" dt="2025-08-18T10:03:07.320" v="7" actId="20577"/>
-        <pc:sldMkLst>
-          <pc:docMk/>
-          <pc:sldMk cId="836289018" sldId="256"/>
-        </pc:sldMkLst>
-      </pc:sldChg>
-      <pc:sldChg chg="del">
-        <pc:chgData name="Jonathan Bollig" userId="8b5d0afe-f106-45e0-8c3f-fd98fa124db1" providerId="ADAL" clId="{891409C9-2319-433B-8001-2E1CE368518E}" dt="2025-08-18T09:57:07.527" v="0" actId="47"/>
-        <pc:sldMkLst>
-          <pc:docMk/>
-          <pc:sldMk cId="3656329933" sldId="257"/>
-        </pc:sldMkLst>
-      </pc:sldChg>
-      <pc:sldChg chg="del">
-        <pc:chgData name="Jonathan Bollig" userId="8b5d0afe-f106-45e0-8c3f-fd98fa124db1" providerId="ADAL" clId="{891409C9-2319-433B-8001-2E1CE368518E}" dt="2025-08-18T09:57:07.527" v="0" actId="47"/>
-        <pc:sldMkLst>
-          <pc:docMk/>
-          <pc:sldMk cId="544279955" sldId="258"/>
-        </pc:sldMkLst>
-      </pc:sldChg>
-      <pc:sldChg chg="delSp modSp del mod">
-        <pc:chgData name="Jonathan Bollig" userId="8b5d0afe-f106-45e0-8c3f-fd98fa124db1" providerId="ADAL" clId="{891409C9-2319-433B-8001-2E1CE368518E}" dt="2025-08-18T13:33:56.347" v="46" actId="47"/>
-        <pc:sldMkLst>
-          <pc:docMk/>
-          <pc:sldMk cId="2169503629" sldId="259"/>
-        </pc:sldMkLst>
-      </pc:sldChg>
-      <pc:sldChg chg="add">
-        <pc:chgData name="Jonathan Bollig" userId="8b5d0afe-f106-45e0-8c3f-fd98fa124db1" providerId="ADAL" clId="{891409C9-2319-433B-8001-2E1CE368518E}" dt="2025-08-18T13:33:54.473" v="45"/>
-        <pc:sldMkLst>
-          <pc:docMk/>
-          <pc:sldMk cId="932306145" sldId="260"/>
-        </pc:sldMkLst>
-      </pc:sldChg>
-      <pc:sldChg chg="del">
-        <pc:chgData name="Jonathan Bollig" userId="8b5d0afe-f106-45e0-8c3f-fd98fa124db1" providerId="ADAL" clId="{891409C9-2319-433B-8001-2E1CE368518E}" dt="2025-08-18T09:57:07.527" v="0" actId="47"/>
-        <pc:sldMkLst>
-          <pc:docMk/>
-          <pc:sldMk cId="2533283895" sldId="260"/>
-        </pc:sldMkLst>
-      </pc:sldChg>
-      <pc:sldChg chg="del">
-        <pc:chgData name="Jonathan Bollig" userId="8b5d0afe-f106-45e0-8c3f-fd98fa124db1" providerId="ADAL" clId="{891409C9-2319-433B-8001-2E1CE368518E}" dt="2025-08-18T09:57:07.527" v="0" actId="47"/>
-        <pc:sldMkLst>
-          <pc:docMk/>
-          <pc:sldMk cId="847849653" sldId="261"/>
-        </pc:sldMkLst>
-      </pc:sldChg>
-      <pc:sldChg chg="del">
-        <pc:chgData name="Jonathan Bollig" userId="8b5d0afe-f106-45e0-8c3f-fd98fa124db1" providerId="ADAL" clId="{891409C9-2319-433B-8001-2E1CE368518E}" dt="2025-08-18T09:57:07.527" v="0" actId="47"/>
-        <pc:sldMkLst>
-          <pc:docMk/>
-          <pc:sldMk cId="1908144578" sldId="262"/>
-        </pc:sldMkLst>
-      </pc:sldChg>
-      <pc:sldChg chg="del">
-        <pc:chgData name="Jonathan Bollig" userId="8b5d0afe-f106-45e0-8c3f-fd98fa124db1" providerId="ADAL" clId="{891409C9-2319-433B-8001-2E1CE368518E}" dt="2025-08-18T09:57:07.527" v="0" actId="47"/>
-        <pc:sldMkLst>
-          <pc:docMk/>
-          <pc:sldMk cId="4076698392" sldId="263"/>
-        </pc:sldMkLst>
-      </pc:sldChg>
-      <pc:sldChg chg="del">
-        <pc:chgData name="Jonathan Bollig" userId="8b5d0afe-f106-45e0-8c3f-fd98fa124db1" providerId="ADAL" clId="{891409C9-2319-433B-8001-2E1CE368518E}" dt="2025-08-18T09:57:07.527" v="0" actId="47"/>
-        <pc:sldMkLst>
-          <pc:docMk/>
-          <pc:sldMk cId="3708449378" sldId="264"/>
-        </pc:sldMkLst>
-      </pc:sldChg>
-      <pc:sldChg chg="del">
-        <pc:chgData name="Jonathan Bollig" userId="8b5d0afe-f106-45e0-8c3f-fd98fa124db1" providerId="ADAL" clId="{891409C9-2319-433B-8001-2E1CE368518E}" dt="2025-08-18T09:57:07.527" v="0" actId="47"/>
-        <pc:sldMkLst>
-          <pc:docMk/>
-          <pc:sldMk cId="933916611" sldId="265"/>
-        </pc:sldMkLst>
-      </pc:sldChg>
-      <pc:sldChg chg="del">
-        <pc:chgData name="Jonathan Bollig" userId="8b5d0afe-f106-45e0-8c3f-fd98fa124db1" providerId="ADAL" clId="{891409C9-2319-433B-8001-2E1CE368518E}" dt="2025-08-18T09:57:07.527" v="0" actId="47"/>
-        <pc:sldMkLst>
-          <pc:docMk/>
-          <pc:sldMk cId="2117799034" sldId="266"/>
-        </pc:sldMkLst>
-      </pc:sldChg>
-    </pc:docChg>
-  </pc:docChgLst>
 </pc:chgInfo>
 </file>
 
@@ -927,7 +927,7 @@
           <a:p>
             <a:fld id="{0B6CA2EE-5589-4682-AD7F-744DBF1E81F5}" type="datetimeFigureOut">
               <a:rPr lang="de-DE" smtClean="0"/>
-              <a:t>07.10.2025</a:t>
+              <a:t>08.10.2025</a:t>
             </a:fld>
             <a:endParaRPr lang="de-DE"/>
           </a:p>
@@ -1085,7 +1085,7 @@
           <a:p>
             <a:fld id="{11422C3B-6429-4381-8F08-B422F3CD22BF}" type="slidenum">
               <a:rPr lang="de-DE" smtClean="0"/>
-              <a:t>‹Nr.›</a:t>
+              <a:t>‹#›</a:t>
             </a:fld>
             <a:endParaRPr lang="de-DE"/>
           </a:p>
@@ -1341,7 +1341,7 @@
           <a:p>
             <a:fld id="{ADA51F25-4808-47F4-BF6E-BCDC230DB01C}" type="datetimeFigureOut">
               <a:rPr lang="de-DE" smtClean="0"/>
-              <a:t>07.10.2025</a:t>
+              <a:t>08.10.2025</a:t>
             </a:fld>
             <a:endParaRPr lang="de-DE"/>
           </a:p>
@@ -1395,7 +1395,7 @@
           <a:p>
             <a:fld id="{C018A060-D51C-4243-8F88-61D66D5570B8}" type="slidenum">
               <a:rPr lang="de-DE" smtClean="0"/>
-              <a:t>‹Nr.›</a:t>
+              <a:t>‹#›</a:t>
             </a:fld>
             <a:endParaRPr lang="de-DE"/>
           </a:p>
@@ -1539,7 +1539,7 @@
           <a:p>
             <a:fld id="{ADA51F25-4808-47F4-BF6E-BCDC230DB01C}" type="datetimeFigureOut">
               <a:rPr lang="de-DE" smtClean="0"/>
-              <a:t>07.10.2025</a:t>
+              <a:t>08.10.2025</a:t>
             </a:fld>
             <a:endParaRPr lang="de-DE"/>
           </a:p>
@@ -1593,7 +1593,7 @@
           <a:p>
             <a:fld id="{C018A060-D51C-4243-8F88-61D66D5570B8}" type="slidenum">
               <a:rPr lang="de-DE" smtClean="0"/>
-              <a:t>‹Nr.›</a:t>
+              <a:t>‹#›</a:t>
             </a:fld>
             <a:endParaRPr lang="de-DE"/>
           </a:p>
@@ -1747,7 +1747,7 @@
           <a:p>
             <a:fld id="{ADA51F25-4808-47F4-BF6E-BCDC230DB01C}" type="datetimeFigureOut">
               <a:rPr lang="de-DE" smtClean="0"/>
-              <a:t>07.10.2025</a:t>
+              <a:t>08.10.2025</a:t>
             </a:fld>
             <a:endParaRPr lang="de-DE"/>
           </a:p>
@@ -1801,7 +1801,7 @@
           <a:p>
             <a:fld id="{C018A060-D51C-4243-8F88-61D66D5570B8}" type="slidenum">
               <a:rPr lang="de-DE" smtClean="0"/>
-              <a:t>‹Nr.›</a:t>
+              <a:t>‹#›</a:t>
             </a:fld>
             <a:endParaRPr lang="de-DE"/>
           </a:p>
@@ -1945,7 +1945,7 @@
           <a:p>
             <a:fld id="{ADA51F25-4808-47F4-BF6E-BCDC230DB01C}" type="datetimeFigureOut">
               <a:rPr lang="de-DE" smtClean="0"/>
-              <a:t>07.10.2025</a:t>
+              <a:t>08.10.2025</a:t>
             </a:fld>
             <a:endParaRPr lang="de-DE"/>
           </a:p>
@@ -1999,7 +1999,7 @@
           <a:p>
             <a:fld id="{C018A060-D51C-4243-8F88-61D66D5570B8}" type="slidenum">
               <a:rPr lang="de-DE" smtClean="0"/>
-              <a:t>‹Nr.›</a:t>
+              <a:t>‹#›</a:t>
             </a:fld>
             <a:endParaRPr lang="de-DE"/>
           </a:p>
@@ -2220,7 +2220,7 @@
           <a:p>
             <a:fld id="{ADA51F25-4808-47F4-BF6E-BCDC230DB01C}" type="datetimeFigureOut">
               <a:rPr lang="de-DE" smtClean="0"/>
-              <a:t>07.10.2025</a:t>
+              <a:t>08.10.2025</a:t>
             </a:fld>
             <a:endParaRPr lang="de-DE"/>
           </a:p>
@@ -2274,7 +2274,7 @@
           <a:p>
             <a:fld id="{C018A060-D51C-4243-8F88-61D66D5570B8}" type="slidenum">
               <a:rPr lang="de-DE" smtClean="0"/>
-              <a:t>‹Nr.›</a:t>
+              <a:t>‹#›</a:t>
             </a:fld>
             <a:endParaRPr lang="de-DE"/>
           </a:p>
@@ -2485,7 +2485,7 @@
           <a:p>
             <a:fld id="{ADA51F25-4808-47F4-BF6E-BCDC230DB01C}" type="datetimeFigureOut">
               <a:rPr lang="de-DE" smtClean="0"/>
-              <a:t>07.10.2025</a:t>
+              <a:t>08.10.2025</a:t>
             </a:fld>
             <a:endParaRPr lang="de-DE"/>
           </a:p>
@@ -2539,7 +2539,7 @@
           <a:p>
             <a:fld id="{C018A060-D51C-4243-8F88-61D66D5570B8}" type="slidenum">
               <a:rPr lang="de-DE" smtClean="0"/>
-              <a:t>‹Nr.›</a:t>
+              <a:t>‹#›</a:t>
             </a:fld>
             <a:endParaRPr lang="de-DE"/>
           </a:p>
@@ -2897,7 +2897,7 @@
           <a:p>
             <a:fld id="{ADA51F25-4808-47F4-BF6E-BCDC230DB01C}" type="datetimeFigureOut">
               <a:rPr lang="de-DE" smtClean="0"/>
-              <a:t>07.10.2025</a:t>
+              <a:t>08.10.2025</a:t>
             </a:fld>
             <a:endParaRPr lang="de-DE"/>
           </a:p>
@@ -2951,7 +2951,7 @@
           <a:p>
             <a:fld id="{C018A060-D51C-4243-8F88-61D66D5570B8}" type="slidenum">
               <a:rPr lang="de-DE" smtClean="0"/>
-              <a:t>‹Nr.›</a:t>
+              <a:t>‹#›</a:t>
             </a:fld>
             <a:endParaRPr lang="de-DE"/>
           </a:p>
@@ -3038,7 +3038,7 @@
           <a:p>
             <a:fld id="{ADA51F25-4808-47F4-BF6E-BCDC230DB01C}" type="datetimeFigureOut">
               <a:rPr lang="de-DE" smtClean="0"/>
-              <a:t>07.10.2025</a:t>
+              <a:t>08.10.2025</a:t>
             </a:fld>
             <a:endParaRPr lang="de-DE"/>
           </a:p>
@@ -3092,7 +3092,7 @@
           <a:p>
             <a:fld id="{C018A060-D51C-4243-8F88-61D66D5570B8}" type="slidenum">
               <a:rPr lang="de-DE" smtClean="0"/>
-              <a:t>‹Nr.›</a:t>
+              <a:t>‹#›</a:t>
             </a:fld>
             <a:endParaRPr lang="de-DE"/>
           </a:p>
@@ -3151,7 +3151,7 @@
           <a:p>
             <a:fld id="{ADA51F25-4808-47F4-BF6E-BCDC230DB01C}" type="datetimeFigureOut">
               <a:rPr lang="de-DE" smtClean="0"/>
-              <a:t>07.10.2025</a:t>
+              <a:t>08.10.2025</a:t>
             </a:fld>
             <a:endParaRPr lang="de-DE"/>
           </a:p>
@@ -3205,7 +3205,7 @@
           <a:p>
             <a:fld id="{C018A060-D51C-4243-8F88-61D66D5570B8}" type="slidenum">
               <a:rPr lang="de-DE" smtClean="0"/>
-              <a:t>‹Nr.›</a:t>
+              <a:t>‹#›</a:t>
             </a:fld>
             <a:endParaRPr lang="de-DE"/>
           </a:p>
@@ -3462,7 +3462,7 @@
           <a:p>
             <a:fld id="{ADA51F25-4808-47F4-BF6E-BCDC230DB01C}" type="datetimeFigureOut">
               <a:rPr lang="de-DE" smtClean="0"/>
-              <a:t>07.10.2025</a:t>
+              <a:t>08.10.2025</a:t>
             </a:fld>
             <a:endParaRPr lang="de-DE"/>
           </a:p>
@@ -3516,7 +3516,7 @@
           <a:p>
             <a:fld id="{C018A060-D51C-4243-8F88-61D66D5570B8}" type="slidenum">
               <a:rPr lang="de-DE" smtClean="0"/>
-              <a:t>‹Nr.›</a:t>
+              <a:t>‹#›</a:t>
             </a:fld>
             <a:endParaRPr lang="de-DE"/>
           </a:p>
@@ -3750,7 +3750,7 @@
           <a:p>
             <a:fld id="{ADA51F25-4808-47F4-BF6E-BCDC230DB01C}" type="datetimeFigureOut">
               <a:rPr lang="de-DE" smtClean="0"/>
-              <a:t>07.10.2025</a:t>
+              <a:t>08.10.2025</a:t>
             </a:fld>
             <a:endParaRPr lang="de-DE"/>
           </a:p>
@@ -3804,7 +3804,7 @@
           <a:p>
             <a:fld id="{C018A060-D51C-4243-8F88-61D66D5570B8}" type="slidenum">
               <a:rPr lang="de-DE" smtClean="0"/>
-              <a:t>‹Nr.›</a:t>
+              <a:t>‹#›</a:t>
             </a:fld>
             <a:endParaRPr lang="de-DE"/>
           </a:p>
@@ -3991,7 +3991,7 @@
           <a:p>
             <a:fld id="{ADA51F25-4808-47F4-BF6E-BCDC230DB01C}" type="datetimeFigureOut">
               <a:rPr lang="de-DE" smtClean="0"/>
-              <a:t>07.10.2025</a:t>
+              <a:t>08.10.2025</a:t>
             </a:fld>
             <a:endParaRPr lang="de-DE"/>
           </a:p>
@@ -4081,7 +4081,7 @@
           <a:p>
             <a:fld id="{C018A060-D51C-4243-8F88-61D66D5570B8}" type="slidenum">
               <a:rPr lang="de-DE" smtClean="0"/>
-              <a:t>‹Nr.›</a:t>
+              <a:t>‹#›</a:t>
             </a:fld>
             <a:endParaRPr lang="de-DE"/>
           </a:p>
@@ -4424,7 +4424,12 @@
             <p:ph type="ctrTitle"/>
           </p:nvPr>
         </p:nvSpPr>
-        <p:spPr/>
+        <p:spPr>
+          <a:xfrm>
+            <a:off x="1524000" y="1573776"/>
+            <a:ext cx="9144000" cy="2387600"/>
+          </a:xfrm>
+        </p:spPr>
         <p:txBody>
           <a:bodyPr>
             <a:normAutofit fontScale="90000"/>
@@ -4445,35 +4450,34 @@
             <a:br>
               <a:rPr lang="en-US" noProof="0" dirty="0"/>
             </a:br>
-            <a:r>
+            <a:br>
               <a:rPr lang="en-US" noProof="0" dirty="0"/>
+            </a:br>
+            <a:r>
+              <a:rPr lang="en-US" b="1" noProof="0" dirty="0"/>
               <a:t>Chunk 1</a:t>
             </a:r>
             <a:r>
-              <a:rPr lang="en-US"/>
+              <a:rPr lang="en-US" b="1" dirty="0"/>
               <a:t>0</a:t>
             </a:r>
             <a:r>
-              <a:rPr lang="en-US" noProof="0"/>
-              <a:t>: </a:t>
-            </a:r>
-            <a:r>
-              <a:rPr lang="en-US" noProof="0" dirty="0"/>
-              <a:t>2D </a:t>
-            </a:r>
-            <a:r>
-              <a:rPr lang="en-US" noProof="0" dirty="0" err="1"/>
+              <a:rPr lang="en-US" b="1" noProof="0" dirty="0"/>
+              <a:t>: 2D </a:t>
+            </a:r>
+            <a:r>
+              <a:rPr lang="en-US" b="1" noProof="0" dirty="0" err="1"/>
               <a:t>numpy</a:t>
             </a:r>
             <a:r>
-              <a:rPr lang="en-US" noProof="0" dirty="0"/>
+              <a:rPr lang="en-US" b="1" noProof="0" dirty="0"/>
               <a:t> and </a:t>
             </a:r>
             <a:r>
-              <a:rPr lang="en-US" noProof="0" dirty="0" err="1"/>
+              <a:rPr lang="en-US" b="1" noProof="0" dirty="0" err="1"/>
               <a:t>mpl</a:t>
             </a:r>
-            <a:endParaRPr lang="en-US" noProof="0" dirty="0"/>
+            <a:endParaRPr lang="en-US" b="1" noProof="0" dirty="0"/>
           </a:p>
         </p:txBody>
       </p:sp>
@@ -4493,7 +4497,12 @@
             <p:ph type="subTitle" idx="1"/>
           </p:nvPr>
         </p:nvSpPr>
-        <p:spPr/>
+        <p:spPr>
+          <a:xfrm>
+            <a:off x="1524000" y="4609036"/>
+            <a:ext cx="9144000" cy="1655762"/>
+          </a:xfrm>
+        </p:spPr>
         <p:txBody>
           <a:bodyPr/>
           <a:lstStyle/>
@@ -4811,6 +4820,291 @@
   <p:clrMapOvr>
     <a:masterClrMapping/>
   </p:clrMapOvr>
+  <p:timing>
+    <p:tnLst>
+      <p:par>
+        <p:cTn id="1" dur="indefinite" restart="never" nodeType="tmRoot">
+          <p:childTnLst>
+            <p:seq concurrent="1" nextAc="seek">
+              <p:cTn id="2" dur="indefinite" nodeType="mainSeq">
+                <p:childTnLst>
+                  <p:par>
+                    <p:cTn id="3" fill="hold">
+                      <p:stCondLst>
+                        <p:cond delay="indefinite"/>
+                      </p:stCondLst>
+                      <p:childTnLst>
+                        <p:par>
+                          <p:cTn id="4" fill="hold">
+                            <p:stCondLst>
+                              <p:cond delay="0"/>
+                            </p:stCondLst>
+                            <p:childTnLst>
+                              <p:par>
+                                <p:cTn id="5" presetID="1" presetClass="entr" presetSubtype="0" fill="hold" nodeType="clickEffect">
+                                  <p:stCondLst>
+                                    <p:cond delay="0"/>
+                                  </p:stCondLst>
+                                  <p:childTnLst>
+                                    <p:set>
+                                      <p:cBhvr>
+                                        <p:cTn id="6" dur="1" fill="hold">
+                                          <p:stCondLst>
+                                            <p:cond delay="0"/>
+                                          </p:stCondLst>
+                                        </p:cTn>
+                                        <p:tgtEl>
+                                          <p:spTgt spid="3">
+                                            <p:txEl>
+                                              <p:pRg st="1" end="1"/>
+                                            </p:txEl>
+                                          </p:spTgt>
+                                        </p:tgtEl>
+                                        <p:attrNameLst>
+                                          <p:attrName>style.visibility</p:attrName>
+                                        </p:attrNameLst>
+                                      </p:cBhvr>
+                                      <p:to>
+                                        <p:strVal val="visible"/>
+                                      </p:to>
+                                    </p:set>
+                                  </p:childTnLst>
+                                </p:cTn>
+                              </p:par>
+                            </p:childTnLst>
+                          </p:cTn>
+                        </p:par>
+                      </p:childTnLst>
+                    </p:cTn>
+                  </p:par>
+                  <p:par>
+                    <p:cTn id="7" fill="hold">
+                      <p:stCondLst>
+                        <p:cond delay="indefinite"/>
+                      </p:stCondLst>
+                      <p:childTnLst>
+                        <p:par>
+                          <p:cTn id="8" fill="hold">
+                            <p:stCondLst>
+                              <p:cond delay="0"/>
+                            </p:stCondLst>
+                            <p:childTnLst>
+                              <p:par>
+                                <p:cTn id="9" presetID="1" presetClass="entr" presetSubtype="0" fill="hold" nodeType="clickEffect">
+                                  <p:stCondLst>
+                                    <p:cond delay="0"/>
+                                  </p:stCondLst>
+                                  <p:childTnLst>
+                                    <p:set>
+                                      <p:cBhvr>
+                                        <p:cTn id="10" dur="1" fill="hold">
+                                          <p:stCondLst>
+                                            <p:cond delay="0"/>
+                                          </p:stCondLst>
+                                        </p:cTn>
+                                        <p:tgtEl>
+                                          <p:spTgt spid="3">
+                                            <p:txEl>
+                                              <p:pRg st="3" end="3"/>
+                                            </p:txEl>
+                                          </p:spTgt>
+                                        </p:tgtEl>
+                                        <p:attrNameLst>
+                                          <p:attrName>style.visibility</p:attrName>
+                                        </p:attrNameLst>
+                                      </p:cBhvr>
+                                      <p:to>
+                                        <p:strVal val="visible"/>
+                                      </p:to>
+                                    </p:set>
+                                  </p:childTnLst>
+                                </p:cTn>
+                              </p:par>
+                              <p:par>
+                                <p:cTn id="11" presetID="1" presetClass="entr" presetSubtype="0" fill="hold" nodeType="withEffect">
+                                  <p:stCondLst>
+                                    <p:cond delay="0"/>
+                                  </p:stCondLst>
+                                  <p:childTnLst>
+                                    <p:set>
+                                      <p:cBhvr>
+                                        <p:cTn id="12" dur="1" fill="hold">
+                                          <p:stCondLst>
+                                            <p:cond delay="0"/>
+                                          </p:stCondLst>
+                                        </p:cTn>
+                                        <p:tgtEl>
+                                          <p:spTgt spid="7"/>
+                                        </p:tgtEl>
+                                        <p:attrNameLst>
+                                          <p:attrName>style.visibility</p:attrName>
+                                        </p:attrNameLst>
+                                      </p:cBhvr>
+                                      <p:to>
+                                        <p:strVal val="visible"/>
+                                      </p:to>
+                                    </p:set>
+                                  </p:childTnLst>
+                                </p:cTn>
+                              </p:par>
+                              <p:par>
+                                <p:cTn id="13" presetID="1" presetClass="entr" presetSubtype="0" fill="hold" nodeType="withEffect">
+                                  <p:stCondLst>
+                                    <p:cond delay="0"/>
+                                  </p:stCondLst>
+                                  <p:childTnLst>
+                                    <p:set>
+                                      <p:cBhvr>
+                                        <p:cTn id="14" dur="1" fill="hold">
+                                          <p:stCondLst>
+                                            <p:cond delay="0"/>
+                                          </p:stCondLst>
+                                        </p:cTn>
+                                        <p:tgtEl>
+                                          <p:spTgt spid="5"/>
+                                        </p:tgtEl>
+                                        <p:attrNameLst>
+                                          <p:attrName>style.visibility</p:attrName>
+                                        </p:attrNameLst>
+                                      </p:cBhvr>
+                                      <p:to>
+                                        <p:strVal val="visible"/>
+                                      </p:to>
+                                    </p:set>
+                                  </p:childTnLst>
+                                </p:cTn>
+                              </p:par>
+                              <p:par>
+                                <p:cTn id="15" presetID="1" presetClass="entr" presetSubtype="0" fill="hold" nodeType="withEffect">
+                                  <p:stCondLst>
+                                    <p:cond delay="0"/>
+                                  </p:stCondLst>
+                                  <p:childTnLst>
+                                    <p:set>
+                                      <p:cBhvr>
+                                        <p:cTn id="16" dur="1" fill="hold">
+                                          <p:stCondLst>
+                                            <p:cond delay="0"/>
+                                          </p:stCondLst>
+                                        </p:cTn>
+                                        <p:tgtEl>
+                                          <p:spTgt spid="6"/>
+                                        </p:tgtEl>
+                                        <p:attrNameLst>
+                                          <p:attrName>style.visibility</p:attrName>
+                                        </p:attrNameLst>
+                                      </p:cBhvr>
+                                      <p:to>
+                                        <p:strVal val="visible"/>
+                                      </p:to>
+                                    </p:set>
+                                  </p:childTnLst>
+                                </p:cTn>
+                              </p:par>
+                            </p:childTnLst>
+                          </p:cTn>
+                        </p:par>
+                      </p:childTnLst>
+                    </p:cTn>
+                  </p:par>
+                  <p:par>
+                    <p:cTn id="17" fill="hold">
+                      <p:stCondLst>
+                        <p:cond delay="indefinite"/>
+                      </p:stCondLst>
+                      <p:childTnLst>
+                        <p:par>
+                          <p:cTn id="18" fill="hold">
+                            <p:stCondLst>
+                              <p:cond delay="0"/>
+                            </p:stCondLst>
+                            <p:childTnLst>
+                              <p:par>
+                                <p:cTn id="19" presetID="1" presetClass="entr" presetSubtype="0" fill="hold" nodeType="clickEffect">
+                                  <p:stCondLst>
+                                    <p:cond delay="0"/>
+                                  </p:stCondLst>
+                                  <p:childTnLst>
+                                    <p:set>
+                                      <p:cBhvr>
+                                        <p:cTn id="20" dur="1" fill="hold">
+                                          <p:stCondLst>
+                                            <p:cond delay="0"/>
+                                          </p:stCondLst>
+                                        </p:cTn>
+                                        <p:tgtEl>
+                                          <p:spTgt spid="3">
+                                            <p:txEl>
+                                              <p:pRg st="5" end="5"/>
+                                            </p:txEl>
+                                          </p:spTgt>
+                                        </p:tgtEl>
+                                        <p:attrNameLst>
+                                          <p:attrName>style.visibility</p:attrName>
+                                        </p:attrNameLst>
+                                      </p:cBhvr>
+                                      <p:to>
+                                        <p:strVal val="visible"/>
+                                      </p:to>
+                                    </p:set>
+                                  </p:childTnLst>
+                                </p:cTn>
+                              </p:par>
+                              <p:par>
+                                <p:cTn id="21" presetID="1" presetClass="entr" presetSubtype="0" fill="hold" nodeType="withEffect">
+                                  <p:stCondLst>
+                                    <p:cond delay="0"/>
+                                  </p:stCondLst>
+                                  <p:childTnLst>
+                                    <p:set>
+                                      <p:cBhvr>
+                                        <p:cTn id="22" dur="1" fill="hold">
+                                          <p:stCondLst>
+                                            <p:cond delay="0"/>
+                                          </p:stCondLst>
+                                        </p:cTn>
+                                        <p:tgtEl>
+                                          <p:spTgt spid="9"/>
+                                        </p:tgtEl>
+                                        <p:attrNameLst>
+                                          <p:attrName>style.visibility</p:attrName>
+                                        </p:attrNameLst>
+                                      </p:cBhvr>
+                                      <p:to>
+                                        <p:strVal val="visible"/>
+                                      </p:to>
+                                    </p:set>
+                                  </p:childTnLst>
+                                </p:cTn>
+                              </p:par>
+                            </p:childTnLst>
+                          </p:cTn>
+                        </p:par>
+                      </p:childTnLst>
+                    </p:cTn>
+                  </p:par>
+                </p:childTnLst>
+              </p:cTn>
+              <p:prevCondLst>
+                <p:cond evt="onPrev" delay="0">
+                  <p:tgtEl>
+                    <p:sldTgt/>
+                  </p:tgtEl>
+                </p:cond>
+              </p:prevCondLst>
+              <p:nextCondLst>
+                <p:cond evt="onNext" delay="0">
+                  <p:tgtEl>
+                    <p:sldTgt/>
+                  </p:tgtEl>
+                </p:cond>
+              </p:nextCondLst>
+            </p:seq>
+          </p:childTnLst>
+        </p:cTn>
+      </p:par>
+    </p:tnLst>
+  </p:timing>
 </p:sld>
 </file>
 
@@ -4891,7 +5185,12 @@
             <p:ph idx="1"/>
           </p:nvPr>
         </p:nvSpPr>
-        <p:spPr/>
+        <p:spPr>
+          <a:xfrm>
+            <a:off x="838200" y="2118003"/>
+            <a:ext cx="10515600" cy="4351338"/>
+          </a:xfrm>
+        </p:spPr>
         <p:txBody>
           <a:bodyPr/>
           <a:lstStyle/>
@@ -5021,7 +5320,7 @@
         </p:blipFill>
         <p:spPr>
           <a:xfrm>
-            <a:off x="3241358" y="1431533"/>
+            <a:off x="3241358" y="1690688"/>
             <a:ext cx="3340312" cy="1795731"/>
           </a:xfrm>
           <a:prstGeom prst="rect">
@@ -5049,6 +5348,147 @@
   <p:clrMapOvr>
     <a:masterClrMapping/>
   </p:clrMapOvr>
+  <p:timing>
+    <p:tnLst>
+      <p:par>
+        <p:cTn id="1" dur="indefinite" restart="never" nodeType="tmRoot">
+          <p:childTnLst>
+            <p:seq concurrent="1" nextAc="seek">
+              <p:cTn id="2" dur="indefinite" nodeType="mainSeq">
+                <p:childTnLst>
+                  <p:par>
+                    <p:cTn id="3" fill="hold">
+                      <p:stCondLst>
+                        <p:cond delay="indefinite"/>
+                      </p:stCondLst>
+                      <p:childTnLst>
+                        <p:par>
+                          <p:cTn id="4" fill="hold">
+                            <p:stCondLst>
+                              <p:cond delay="0"/>
+                            </p:stCondLst>
+                            <p:childTnLst>
+                              <p:par>
+                                <p:cTn id="5" presetID="1" presetClass="entr" presetSubtype="0" fill="hold" nodeType="clickEffect">
+                                  <p:stCondLst>
+                                    <p:cond delay="0"/>
+                                  </p:stCondLst>
+                                  <p:childTnLst>
+                                    <p:set>
+                                      <p:cBhvr>
+                                        <p:cTn id="6" dur="1" fill="hold">
+                                          <p:stCondLst>
+                                            <p:cond delay="0"/>
+                                          </p:stCondLst>
+                                        </p:cTn>
+                                        <p:tgtEl>
+                                          <p:spTgt spid="3">
+                                            <p:txEl>
+                                              <p:pRg st="4" end="4"/>
+                                            </p:txEl>
+                                          </p:spTgt>
+                                        </p:tgtEl>
+                                        <p:attrNameLst>
+                                          <p:attrName>style.visibility</p:attrName>
+                                        </p:attrNameLst>
+                                      </p:cBhvr>
+                                      <p:to>
+                                        <p:strVal val="visible"/>
+                                      </p:to>
+                                    </p:set>
+                                  </p:childTnLst>
+                                </p:cTn>
+                              </p:par>
+                              <p:par>
+                                <p:cTn id="7" presetID="1" presetClass="entr" presetSubtype="0" fill="hold" nodeType="withEffect">
+                                  <p:stCondLst>
+                                    <p:cond delay="0"/>
+                                  </p:stCondLst>
+                                  <p:childTnLst>
+                                    <p:set>
+                                      <p:cBhvr>
+                                        <p:cTn id="8" dur="1" fill="hold">
+                                          <p:stCondLst>
+                                            <p:cond delay="0"/>
+                                          </p:stCondLst>
+                                        </p:cTn>
+                                        <p:tgtEl>
+                                          <p:spTgt spid="3">
+                                            <p:txEl>
+                                              <p:pRg st="5" end="5"/>
+                                            </p:txEl>
+                                          </p:spTgt>
+                                        </p:tgtEl>
+                                        <p:attrNameLst>
+                                          <p:attrName>style.visibility</p:attrName>
+                                        </p:attrNameLst>
+                                      </p:cBhvr>
+                                      <p:to>
+                                        <p:strVal val="visible"/>
+                                      </p:to>
+                                    </p:set>
+                                  </p:childTnLst>
+                                </p:cTn>
+                              </p:par>
+                              <p:par>
+                                <p:cTn id="9" presetID="1" presetClass="entr" presetSubtype="0" fill="hold" nodeType="withEffect">
+                                  <p:stCondLst>
+                                    <p:cond delay="0"/>
+                                  </p:stCondLst>
+                                  <p:childTnLst>
+                                    <p:set>
+                                      <p:cBhvr>
+                                        <p:cTn id="10" dur="1" fill="hold">
+                                          <p:stCondLst>
+                                            <p:cond delay="0"/>
+                                          </p:stCondLst>
+                                        </p:cTn>
+                                        <p:tgtEl>
+                                          <p:spTgt spid="3">
+                                            <p:txEl>
+                                              <p:pRg st="6" end="6"/>
+                                            </p:txEl>
+                                          </p:spTgt>
+                                        </p:tgtEl>
+                                        <p:attrNameLst>
+                                          <p:attrName>style.visibility</p:attrName>
+                                        </p:attrNameLst>
+                                      </p:cBhvr>
+                                      <p:to>
+                                        <p:strVal val="visible"/>
+                                      </p:to>
+                                    </p:set>
+                                  </p:childTnLst>
+                                </p:cTn>
+                              </p:par>
+                            </p:childTnLst>
+                          </p:cTn>
+                        </p:par>
+                      </p:childTnLst>
+                    </p:cTn>
+                  </p:par>
+                </p:childTnLst>
+              </p:cTn>
+              <p:prevCondLst>
+                <p:cond evt="onPrev" delay="0">
+                  <p:tgtEl>
+                    <p:sldTgt/>
+                  </p:tgtEl>
+                </p:cond>
+              </p:prevCondLst>
+              <p:nextCondLst>
+                <p:cond evt="onNext" delay="0">
+                  <p:tgtEl>
+                    <p:sldTgt/>
+                  </p:tgtEl>
+                </p:cond>
+              </p:nextCondLst>
+            </p:seq>
+          </p:childTnLst>
+        </p:cTn>
+      </p:par>
+    </p:tnLst>
+  </p:timing>
 </p:sld>
 </file>
 
@@ -5428,7 +5868,7 @@
         </p:blipFill>
         <p:spPr>
           <a:xfrm>
-            <a:off x="6955659" y="4859841"/>
+            <a:off x="7172987" y="4978014"/>
             <a:ext cx="2801289" cy="1514861"/>
           </a:xfrm>
           <a:prstGeom prst="rect">
@@ -5456,6 +5896,242 @@
   <p:clrMapOvr>
     <a:masterClrMapping/>
   </p:clrMapOvr>
+  <p:timing>
+    <p:tnLst>
+      <p:par>
+        <p:cTn id="1" dur="indefinite" restart="never" nodeType="tmRoot">
+          <p:childTnLst>
+            <p:seq concurrent="1" nextAc="seek">
+              <p:cTn id="2" dur="indefinite" nodeType="mainSeq">
+                <p:childTnLst>
+                  <p:par>
+                    <p:cTn id="3" fill="hold">
+                      <p:stCondLst>
+                        <p:cond delay="indefinite"/>
+                      </p:stCondLst>
+                      <p:childTnLst>
+                        <p:par>
+                          <p:cTn id="4" fill="hold">
+                            <p:stCondLst>
+                              <p:cond delay="0"/>
+                            </p:stCondLst>
+                            <p:childTnLst>
+                              <p:par>
+                                <p:cTn id="5" presetID="1" presetClass="entr" presetSubtype="0" fill="hold" nodeType="clickEffect">
+                                  <p:stCondLst>
+                                    <p:cond delay="0"/>
+                                  </p:stCondLst>
+                                  <p:childTnLst>
+                                    <p:set>
+                                      <p:cBhvr>
+                                        <p:cTn id="6" dur="1" fill="hold">
+                                          <p:stCondLst>
+                                            <p:cond delay="0"/>
+                                          </p:stCondLst>
+                                        </p:cTn>
+                                        <p:tgtEl>
+                                          <p:spTgt spid="7"/>
+                                        </p:tgtEl>
+                                        <p:attrNameLst>
+                                          <p:attrName>style.visibility</p:attrName>
+                                        </p:attrNameLst>
+                                      </p:cBhvr>
+                                      <p:to>
+                                        <p:strVal val="visible"/>
+                                      </p:to>
+                                    </p:set>
+                                  </p:childTnLst>
+                                </p:cTn>
+                              </p:par>
+                              <p:par>
+                                <p:cTn id="7" presetID="1" presetClass="entr" presetSubtype="0" fill="hold" nodeType="withEffect">
+                                  <p:stCondLst>
+                                    <p:cond delay="0"/>
+                                  </p:stCondLst>
+                                  <p:childTnLst>
+                                    <p:set>
+                                      <p:cBhvr>
+                                        <p:cTn id="8" dur="1" fill="hold">
+                                          <p:stCondLst>
+                                            <p:cond delay="0"/>
+                                          </p:stCondLst>
+                                        </p:cTn>
+                                        <p:tgtEl>
+                                          <p:spTgt spid="9"/>
+                                        </p:tgtEl>
+                                        <p:attrNameLst>
+                                          <p:attrName>style.visibility</p:attrName>
+                                        </p:attrNameLst>
+                                      </p:cBhvr>
+                                      <p:to>
+                                        <p:strVal val="visible"/>
+                                      </p:to>
+                                    </p:set>
+                                  </p:childTnLst>
+                                </p:cTn>
+                              </p:par>
+                              <p:par>
+                                <p:cTn id="9" presetID="1" presetClass="entr" presetSubtype="0" fill="hold" nodeType="withEffect">
+                                  <p:stCondLst>
+                                    <p:cond delay="0"/>
+                                  </p:stCondLst>
+                                  <p:childTnLst>
+                                    <p:set>
+                                      <p:cBhvr>
+                                        <p:cTn id="10" dur="1" fill="hold">
+                                          <p:stCondLst>
+                                            <p:cond delay="0"/>
+                                          </p:stCondLst>
+                                        </p:cTn>
+                                        <p:tgtEl>
+                                          <p:spTgt spid="10"/>
+                                        </p:tgtEl>
+                                        <p:attrNameLst>
+                                          <p:attrName>style.visibility</p:attrName>
+                                        </p:attrNameLst>
+                                      </p:cBhvr>
+                                      <p:to>
+                                        <p:strVal val="visible"/>
+                                      </p:to>
+                                    </p:set>
+                                  </p:childTnLst>
+                                </p:cTn>
+                              </p:par>
+                              <p:par>
+                                <p:cTn id="11" presetID="1" presetClass="entr" presetSubtype="0" fill="hold" nodeType="withEffect">
+                                  <p:stCondLst>
+                                    <p:cond delay="0"/>
+                                  </p:stCondLst>
+                                  <p:childTnLst>
+                                    <p:set>
+                                      <p:cBhvr>
+                                        <p:cTn id="12" dur="1" fill="hold">
+                                          <p:stCondLst>
+                                            <p:cond delay="0"/>
+                                          </p:stCondLst>
+                                        </p:cTn>
+                                        <p:tgtEl>
+                                          <p:spTgt spid="3">
+                                            <p:txEl>
+                                              <p:pRg st="5" end="5"/>
+                                            </p:txEl>
+                                          </p:spTgt>
+                                        </p:tgtEl>
+                                        <p:attrNameLst>
+                                          <p:attrName>style.visibility</p:attrName>
+                                        </p:attrNameLst>
+                                      </p:cBhvr>
+                                      <p:to>
+                                        <p:strVal val="visible"/>
+                                      </p:to>
+                                    </p:set>
+                                  </p:childTnLst>
+                                </p:cTn>
+                              </p:par>
+                            </p:childTnLst>
+                          </p:cTn>
+                        </p:par>
+                      </p:childTnLst>
+                    </p:cTn>
+                  </p:par>
+                  <p:par>
+                    <p:cTn id="13" fill="hold">
+                      <p:stCondLst>
+                        <p:cond delay="indefinite"/>
+                      </p:stCondLst>
+                      <p:childTnLst>
+                        <p:par>
+                          <p:cTn id="14" fill="hold">
+                            <p:stCondLst>
+                              <p:cond delay="0"/>
+                            </p:stCondLst>
+                            <p:childTnLst>
+                              <p:par>
+                                <p:cTn id="15" presetID="1" presetClass="entr" presetSubtype="0" fill="hold" nodeType="clickEffect">
+                                  <p:stCondLst>
+                                    <p:cond delay="0"/>
+                                  </p:stCondLst>
+                                  <p:childTnLst>
+                                    <p:set>
+                                      <p:cBhvr>
+                                        <p:cTn id="16" dur="1" fill="hold">
+                                          <p:stCondLst>
+                                            <p:cond delay="0"/>
+                                          </p:stCondLst>
+                                        </p:cTn>
+                                        <p:tgtEl>
+                                          <p:spTgt spid="3">
+                                            <p:txEl>
+                                              <p:pRg st="7" end="7"/>
+                                            </p:txEl>
+                                          </p:spTgt>
+                                        </p:tgtEl>
+                                        <p:attrNameLst>
+                                          <p:attrName>style.visibility</p:attrName>
+                                        </p:attrNameLst>
+                                      </p:cBhvr>
+                                      <p:to>
+                                        <p:strVal val="visible"/>
+                                      </p:to>
+                                    </p:set>
+                                  </p:childTnLst>
+                                </p:cTn>
+                              </p:par>
+                              <p:par>
+                                <p:cTn id="17" presetID="1" presetClass="entr" presetSubtype="0" fill="hold" nodeType="withEffect">
+                                  <p:stCondLst>
+                                    <p:cond delay="0"/>
+                                  </p:stCondLst>
+                                  <p:childTnLst>
+                                    <p:set>
+                                      <p:cBhvr>
+                                        <p:cTn id="18" dur="1" fill="hold">
+                                          <p:stCondLst>
+                                            <p:cond delay="0"/>
+                                          </p:stCondLst>
+                                        </p:cTn>
+                                        <p:tgtEl>
+                                          <p:spTgt spid="14"/>
+                                        </p:tgtEl>
+                                        <p:attrNameLst>
+                                          <p:attrName>style.visibility</p:attrName>
+                                        </p:attrNameLst>
+                                      </p:cBhvr>
+                                      <p:to>
+                                        <p:strVal val="visible"/>
+                                      </p:to>
+                                    </p:set>
+                                  </p:childTnLst>
+                                </p:cTn>
+                              </p:par>
+                            </p:childTnLst>
+                          </p:cTn>
+                        </p:par>
+                      </p:childTnLst>
+                    </p:cTn>
+                  </p:par>
+                </p:childTnLst>
+              </p:cTn>
+              <p:prevCondLst>
+                <p:cond evt="onPrev" delay="0">
+                  <p:tgtEl>
+                    <p:sldTgt/>
+                  </p:tgtEl>
+                </p:cond>
+              </p:prevCondLst>
+              <p:nextCondLst>
+                <p:cond evt="onNext" delay="0">
+                  <p:tgtEl>
+                    <p:sldTgt/>
+                  </p:tgtEl>
+                </p:cond>
+              </p:nextCondLst>
+            </p:seq>
+          </p:childTnLst>
+        </p:cTn>
+      </p:par>
+    </p:tnLst>
+  </p:timing>
 </p:sld>
 </file>
 
@@ -5520,7 +6196,12 @@
             <p:ph idx="1"/>
           </p:nvPr>
         </p:nvSpPr>
-        <p:spPr/>
+        <p:spPr>
+          <a:xfrm>
+            <a:off x="838200" y="2141537"/>
+            <a:ext cx="10515600" cy="4351338"/>
+          </a:xfrm>
+        </p:spPr>
         <p:txBody>
           <a:bodyPr/>
           <a:lstStyle/>
@@ -5581,7 +6262,7 @@
         </p:blipFill>
         <p:spPr>
           <a:xfrm>
-            <a:off x="8006534" y="2524086"/>
+            <a:off x="7983385" y="2681210"/>
             <a:ext cx="2887680" cy="1036345"/>
           </a:xfrm>
           <a:prstGeom prst="rect">
@@ -5621,7 +6302,7 @@
         </p:blipFill>
         <p:spPr>
           <a:xfrm>
-            <a:off x="8339904" y="3670308"/>
+            <a:off x="8316755" y="3942980"/>
             <a:ext cx="2887680" cy="1041282"/>
           </a:xfrm>
           <a:prstGeom prst="rect">
@@ -6512,7 +7193,7 @@
         </p:nvSpPr>
         <p:spPr>
           <a:xfrm>
-            <a:off x="838200" y="1130395"/>
+            <a:off x="838200" y="936466"/>
             <a:ext cx="10515600" cy="1325563"/>
           </a:xfrm>
         </p:spPr>
@@ -6557,7 +7238,7 @@
         </p:blipFill>
         <p:spPr>
           <a:xfrm>
-            <a:off x="4451840" y="2788920"/>
+            <a:off x="4451840" y="2262029"/>
             <a:ext cx="3288320" cy="3465576"/>
           </a:xfrm>
           <a:prstGeom prst="rect">
@@ -6579,7 +7260,7 @@
         </p:nvSpPr>
         <p:spPr>
           <a:xfrm>
-            <a:off x="4451840" y="6414203"/>
+            <a:off x="4370817" y="5921534"/>
             <a:ext cx="6547946" cy="276999"/>
           </a:xfrm>
           <a:prstGeom prst="rect">

</xml_diff>

<commit_message>
PDFs for day 2 updated
</commit_message>
<xml_diff>
--- a/Lecture Resources/Lecture Powerpoints/Chunk 10 - 2D numpy and mpl.pptx
+++ b/Lecture Resources/Lecture Powerpoints/Chunk 10 - 2D numpy and mpl.pptx
@@ -927,7 +927,7 @@
           <a:p>
             <a:fld id="{0B6CA2EE-5589-4682-AD7F-744DBF1E81F5}" type="datetimeFigureOut">
               <a:rPr lang="de-DE" smtClean="0"/>
-              <a:t>08.10.2025</a:t>
+              <a:t>09.10.2025</a:t>
             </a:fld>
             <a:endParaRPr lang="de-DE"/>
           </a:p>
@@ -1341,7 +1341,7 @@
           <a:p>
             <a:fld id="{ADA51F25-4808-47F4-BF6E-BCDC230DB01C}" type="datetimeFigureOut">
               <a:rPr lang="de-DE" smtClean="0"/>
-              <a:t>08.10.2025</a:t>
+              <a:t>09.10.2025</a:t>
             </a:fld>
             <a:endParaRPr lang="de-DE"/>
           </a:p>
@@ -1539,7 +1539,7 @@
           <a:p>
             <a:fld id="{ADA51F25-4808-47F4-BF6E-BCDC230DB01C}" type="datetimeFigureOut">
               <a:rPr lang="de-DE" smtClean="0"/>
-              <a:t>08.10.2025</a:t>
+              <a:t>09.10.2025</a:t>
             </a:fld>
             <a:endParaRPr lang="de-DE"/>
           </a:p>
@@ -1747,7 +1747,7 @@
           <a:p>
             <a:fld id="{ADA51F25-4808-47F4-BF6E-BCDC230DB01C}" type="datetimeFigureOut">
               <a:rPr lang="de-DE" smtClean="0"/>
-              <a:t>08.10.2025</a:t>
+              <a:t>09.10.2025</a:t>
             </a:fld>
             <a:endParaRPr lang="de-DE"/>
           </a:p>
@@ -1945,7 +1945,7 @@
           <a:p>
             <a:fld id="{ADA51F25-4808-47F4-BF6E-BCDC230DB01C}" type="datetimeFigureOut">
               <a:rPr lang="de-DE" smtClean="0"/>
-              <a:t>08.10.2025</a:t>
+              <a:t>09.10.2025</a:t>
             </a:fld>
             <a:endParaRPr lang="de-DE"/>
           </a:p>
@@ -2220,7 +2220,7 @@
           <a:p>
             <a:fld id="{ADA51F25-4808-47F4-BF6E-BCDC230DB01C}" type="datetimeFigureOut">
               <a:rPr lang="de-DE" smtClean="0"/>
-              <a:t>08.10.2025</a:t>
+              <a:t>09.10.2025</a:t>
             </a:fld>
             <a:endParaRPr lang="de-DE"/>
           </a:p>
@@ -2485,7 +2485,7 @@
           <a:p>
             <a:fld id="{ADA51F25-4808-47F4-BF6E-BCDC230DB01C}" type="datetimeFigureOut">
               <a:rPr lang="de-DE" smtClean="0"/>
-              <a:t>08.10.2025</a:t>
+              <a:t>09.10.2025</a:t>
             </a:fld>
             <a:endParaRPr lang="de-DE"/>
           </a:p>
@@ -2897,7 +2897,7 @@
           <a:p>
             <a:fld id="{ADA51F25-4808-47F4-BF6E-BCDC230DB01C}" type="datetimeFigureOut">
               <a:rPr lang="de-DE" smtClean="0"/>
-              <a:t>08.10.2025</a:t>
+              <a:t>09.10.2025</a:t>
             </a:fld>
             <a:endParaRPr lang="de-DE"/>
           </a:p>
@@ -3038,7 +3038,7 @@
           <a:p>
             <a:fld id="{ADA51F25-4808-47F4-BF6E-BCDC230DB01C}" type="datetimeFigureOut">
               <a:rPr lang="de-DE" smtClean="0"/>
-              <a:t>08.10.2025</a:t>
+              <a:t>09.10.2025</a:t>
             </a:fld>
             <a:endParaRPr lang="de-DE"/>
           </a:p>
@@ -3151,7 +3151,7 @@
           <a:p>
             <a:fld id="{ADA51F25-4808-47F4-BF6E-BCDC230DB01C}" type="datetimeFigureOut">
               <a:rPr lang="de-DE" smtClean="0"/>
-              <a:t>08.10.2025</a:t>
+              <a:t>09.10.2025</a:t>
             </a:fld>
             <a:endParaRPr lang="de-DE"/>
           </a:p>
@@ -3462,7 +3462,7 @@
           <a:p>
             <a:fld id="{ADA51F25-4808-47F4-BF6E-BCDC230DB01C}" type="datetimeFigureOut">
               <a:rPr lang="de-DE" smtClean="0"/>
-              <a:t>08.10.2025</a:t>
+              <a:t>09.10.2025</a:t>
             </a:fld>
             <a:endParaRPr lang="de-DE"/>
           </a:p>
@@ -3750,7 +3750,7 @@
           <a:p>
             <a:fld id="{ADA51F25-4808-47F4-BF6E-BCDC230DB01C}" type="datetimeFigureOut">
               <a:rPr lang="de-DE" smtClean="0"/>
-              <a:t>08.10.2025</a:t>
+              <a:t>09.10.2025</a:t>
             </a:fld>
             <a:endParaRPr lang="de-DE"/>
           </a:p>
@@ -3991,7 +3991,7 @@
           <a:p>
             <a:fld id="{ADA51F25-4808-47F4-BF6E-BCDC230DB01C}" type="datetimeFigureOut">
               <a:rPr lang="de-DE" smtClean="0"/>
-              <a:t>08.10.2025</a:t>
+              <a:t>09.10.2025</a:t>
             </a:fld>
             <a:endParaRPr lang="de-DE"/>
           </a:p>
@@ -7080,6 +7080,13 @@
               <a:rPr lang="en-US" dirty="0"/>
               <a:t> the defines the x and y-scale. Default are pixel.</a:t>
             </a:r>
+          </a:p>
+          <a:p>
+            <a:endParaRPr lang="en-US" dirty="0">
+              <a:highlight>
+                <a:srgbClr val="C0C0C0"/>
+              </a:highlight>
+            </a:endParaRPr>
           </a:p>
           <a:p>
             <a:r>

</xml_diff>